<commit_message>
code:added swagger in the code in file swagger.js and fixed env in app.js
</commit_message>
<xml_diff>
--- a/Diagrams/Flowcharts/Admin Flow Chart.pptx
+++ b/Diagrams/Flowcharts/Admin Flow Chart.pptx
@@ -197,7 +197,7 @@
           <a:p>
             <a:fld id="{9733C882-FF74-4872-B170-11CF9F088A8F}" type="datetimeFigureOut">
               <a:rPr lang="en-US" smtClean="0"/>
-              <a:t>4/17/2026</a:t>
+              <a:t>4/23/2026</a:t>
             </a:fld>
             <a:endParaRPr lang="en-US"/>
           </a:p>
@@ -595,7 +595,7 @@
           <a:p>
             <a:fld id="{7B1AE282-51DF-434B-ABCF-50C8661464C4}" type="datetimeFigureOut">
               <a:rPr lang="en-US" smtClean="0"/>
-              <a:t>4/17/2026</a:t>
+              <a:t>4/23/2026</a:t>
             </a:fld>
             <a:endParaRPr lang="en-US"/>
           </a:p>
@@ -765,7 +765,7 @@
           <a:p>
             <a:fld id="{7B1AE282-51DF-434B-ABCF-50C8661464C4}" type="datetimeFigureOut">
               <a:rPr lang="en-US" smtClean="0"/>
-              <a:t>4/17/2026</a:t>
+              <a:t>4/23/2026</a:t>
             </a:fld>
             <a:endParaRPr lang="en-US"/>
           </a:p>
@@ -945,7 +945,7 @@
           <a:p>
             <a:fld id="{7B1AE282-51DF-434B-ABCF-50C8661464C4}" type="datetimeFigureOut">
               <a:rPr lang="en-US" smtClean="0"/>
-              <a:t>4/17/2026</a:t>
+              <a:t>4/23/2026</a:t>
             </a:fld>
             <a:endParaRPr lang="en-US"/>
           </a:p>
@@ -1115,7 +1115,7 @@
           <a:p>
             <a:fld id="{7B1AE282-51DF-434B-ABCF-50C8661464C4}" type="datetimeFigureOut">
               <a:rPr lang="en-US" smtClean="0"/>
-              <a:t>4/17/2026</a:t>
+              <a:t>4/23/2026</a:t>
             </a:fld>
             <a:endParaRPr lang="en-US"/>
           </a:p>
@@ -1361,7 +1361,7 @@
           <a:p>
             <a:fld id="{7B1AE282-51DF-434B-ABCF-50C8661464C4}" type="datetimeFigureOut">
               <a:rPr lang="en-US" smtClean="0"/>
-              <a:t>4/17/2026</a:t>
+              <a:t>4/23/2026</a:t>
             </a:fld>
             <a:endParaRPr lang="en-US"/>
           </a:p>
@@ -1593,7 +1593,7 @@
           <a:p>
             <a:fld id="{7B1AE282-51DF-434B-ABCF-50C8661464C4}" type="datetimeFigureOut">
               <a:rPr lang="en-US" smtClean="0"/>
-              <a:t>4/17/2026</a:t>
+              <a:t>4/23/2026</a:t>
             </a:fld>
             <a:endParaRPr lang="en-US"/>
           </a:p>
@@ -1960,7 +1960,7 @@
           <a:p>
             <a:fld id="{7B1AE282-51DF-434B-ABCF-50C8661464C4}" type="datetimeFigureOut">
               <a:rPr lang="en-US" smtClean="0"/>
-              <a:t>4/17/2026</a:t>
+              <a:t>4/23/2026</a:t>
             </a:fld>
             <a:endParaRPr lang="en-US"/>
           </a:p>
@@ -2078,7 +2078,7 @@
           <a:p>
             <a:fld id="{7B1AE282-51DF-434B-ABCF-50C8661464C4}" type="datetimeFigureOut">
               <a:rPr lang="en-US" smtClean="0"/>
-              <a:t>4/17/2026</a:t>
+              <a:t>4/23/2026</a:t>
             </a:fld>
             <a:endParaRPr lang="en-US"/>
           </a:p>
@@ -2173,7 +2173,7 @@
           <a:p>
             <a:fld id="{7B1AE282-51DF-434B-ABCF-50C8661464C4}" type="datetimeFigureOut">
               <a:rPr lang="en-US" smtClean="0"/>
-              <a:t>4/17/2026</a:t>
+              <a:t>4/23/2026</a:t>
             </a:fld>
             <a:endParaRPr lang="en-US"/>
           </a:p>
@@ -2450,7 +2450,7 @@
           <a:p>
             <a:fld id="{7B1AE282-51DF-434B-ABCF-50C8661464C4}" type="datetimeFigureOut">
               <a:rPr lang="en-US" smtClean="0"/>
-              <a:t>4/17/2026</a:t>
+              <a:t>4/23/2026</a:t>
             </a:fld>
             <a:endParaRPr lang="en-US"/>
           </a:p>
@@ -2707,7 +2707,7 @@
           <a:p>
             <a:fld id="{7B1AE282-51DF-434B-ABCF-50C8661464C4}" type="datetimeFigureOut">
               <a:rPr lang="en-US" smtClean="0"/>
-              <a:t>4/17/2026</a:t>
+              <a:t>4/23/2026</a:t>
             </a:fld>
             <a:endParaRPr lang="en-US"/>
           </a:p>
@@ -2920,7 +2920,7 @@
           <a:p>
             <a:fld id="{7B1AE282-51DF-434B-ABCF-50C8661464C4}" type="datetimeFigureOut">
               <a:rPr lang="en-US" smtClean="0"/>
-              <a:t>4/17/2026</a:t>
+              <a:t>4/23/2026</a:t>
             </a:fld>
             <a:endParaRPr lang="en-US"/>
           </a:p>
@@ -4207,7 +4207,7 @@
         </p:nvSpPr>
         <p:spPr>
           <a:xfrm>
-            <a:off x="3811126" y="2995013"/>
+            <a:off x="5308837" y="3178477"/>
             <a:ext cx="1397523" cy="957072"/>
           </a:xfrm>
           <a:prstGeom prst="diamond">
@@ -4258,7 +4258,7 @@
         </p:nvCxnSpPr>
         <p:spPr>
           <a:xfrm>
-            <a:off x="4495417" y="3982565"/>
+            <a:off x="5984833" y="4197101"/>
             <a:ext cx="0" cy="262128"/>
           </a:xfrm>
           <a:prstGeom prst="straightConnector1">
@@ -4297,7 +4297,7 @@
         </p:nvSpPr>
         <p:spPr>
           <a:xfrm>
-            <a:off x="4452746" y="3921605"/>
+            <a:off x="6007598" y="4182230"/>
             <a:ext cx="569971" cy="276999"/>
           </a:xfrm>
           <a:prstGeom prst="rect">
@@ -4332,7 +4332,7 @@
         </p:nvSpPr>
         <p:spPr>
           <a:xfrm>
-            <a:off x="3698365" y="4244693"/>
+            <a:off x="5183968" y="4505910"/>
             <a:ext cx="1594104" cy="603504"/>
           </a:xfrm>
           <a:prstGeom prst="parallelogram">
@@ -4367,47 +4367,6 @@
           </a:p>
         </p:txBody>
       </p:sp>
-      <p:cxnSp>
-        <p:nvCxnSpPr>
-          <p:cNvPr id="55" name="Straight Arrow Connector 54">
-            <a:extLst>
-              <a:ext uri="{FF2B5EF4-FFF2-40B4-BE49-F238E27FC236}">
-                <a16:creationId xmlns:a16="http://schemas.microsoft.com/office/drawing/2014/main" id="{39C9F6ED-BAF6-031F-4536-DD092B389993}"/>
-              </a:ext>
-            </a:extLst>
-          </p:cNvPr>
-          <p:cNvCxnSpPr>
-            <a:cxnSpLocks/>
-          </p:cNvCxnSpPr>
-          <p:nvPr/>
-        </p:nvCxnSpPr>
-        <p:spPr>
-          <a:xfrm>
-            <a:off x="6256770" y="2564183"/>
-            <a:ext cx="1" cy="475488"/>
-          </a:xfrm>
-          <a:prstGeom prst="straightConnector1">
-            <a:avLst/>
-          </a:prstGeom>
-          <a:ln>
-            <a:tailEnd type="triangle"/>
-          </a:ln>
-        </p:spPr>
-        <p:style>
-          <a:lnRef idx="2">
-            <a:schemeClr val="accent1"/>
-          </a:lnRef>
-          <a:fillRef idx="0">
-            <a:schemeClr val="accent1"/>
-          </a:fillRef>
-          <a:effectRef idx="1">
-            <a:schemeClr val="accent1"/>
-          </a:effectRef>
-          <a:fontRef idx="minor">
-            <a:schemeClr val="tx1"/>
-          </a:fontRef>
-        </p:style>
-      </p:cxnSp>
       <p:cxnSp>
         <p:nvCxnSpPr>
           <p:cNvPr id="56" name="Straight Connector 55">
@@ -4462,7 +4421,7 @@
         </p:nvCxnSpPr>
         <p:spPr>
           <a:xfrm>
-            <a:off x="4474081" y="4848197"/>
+            <a:off x="5899499" y="5108230"/>
             <a:ext cx="0" cy="262128"/>
           </a:xfrm>
           <a:prstGeom prst="straightConnector1">
@@ -4501,7 +4460,7 @@
         </p:nvSpPr>
         <p:spPr>
           <a:xfrm>
-            <a:off x="3803522" y="5110325"/>
+            <a:off x="5250275" y="5370358"/>
             <a:ext cx="1298448" cy="414528"/>
           </a:xfrm>
           <a:prstGeom prst="ellipse">
@@ -4539,357 +4498,6 @@
       </p:sp>
       <p:sp>
         <p:nvSpPr>
-          <p:cNvPr id="59" name="Diamond 58">
-            <a:extLst>
-              <a:ext uri="{FF2B5EF4-FFF2-40B4-BE49-F238E27FC236}">
-                <a16:creationId xmlns:a16="http://schemas.microsoft.com/office/drawing/2014/main" id="{50878FBE-65D9-2CBA-48C2-0DF4E7957894}"/>
-              </a:ext>
-            </a:extLst>
-          </p:cNvPr>
-          <p:cNvSpPr/>
-          <p:nvPr/>
-        </p:nvSpPr>
-        <p:spPr>
-          <a:xfrm>
-            <a:off x="5611743" y="3009812"/>
-            <a:ext cx="1290054" cy="976978"/>
-          </a:xfrm>
-          <a:prstGeom prst="diamond">
-            <a:avLst/>
-          </a:prstGeom>
-        </p:spPr>
-        <p:style>
-          <a:lnRef idx="2">
-            <a:schemeClr val="accent4">
-              <a:shade val="15000"/>
-            </a:schemeClr>
-          </a:lnRef>
-          <a:fillRef idx="1">
-            <a:schemeClr val="accent4"/>
-          </a:fillRef>
-          <a:effectRef idx="0">
-            <a:schemeClr val="accent4"/>
-          </a:effectRef>
-          <a:fontRef idx="minor">
-            <a:schemeClr val="lt1"/>
-          </a:fontRef>
-        </p:style>
-        <p:txBody>
-          <a:bodyPr rtlCol="0" anchor="ctr"/>
-          <a:lstStyle/>
-          <a:p>
-            <a:pPr algn="ctr"/>
-            <a:r>
-              <a:rPr lang="en-US" sz="1400" dirty="0"/>
-              <a:t>Add client?</a:t>
-            </a:r>
-          </a:p>
-        </p:txBody>
-      </p:sp>
-      <p:cxnSp>
-        <p:nvCxnSpPr>
-          <p:cNvPr id="60" name="Straight Arrow Connector 59">
-            <a:extLst>
-              <a:ext uri="{FF2B5EF4-FFF2-40B4-BE49-F238E27FC236}">
-                <a16:creationId xmlns:a16="http://schemas.microsoft.com/office/drawing/2014/main" id="{D90BADB7-8D8F-4E30-8538-CC7F7B61351A}"/>
-              </a:ext>
-            </a:extLst>
-          </p:cNvPr>
-          <p:cNvCxnSpPr>
-            <a:cxnSpLocks/>
-          </p:cNvCxnSpPr>
-          <p:nvPr/>
-        </p:nvCxnSpPr>
-        <p:spPr>
-          <a:xfrm>
-            <a:off x="6256770" y="3996743"/>
-            <a:ext cx="0" cy="262128"/>
-          </a:xfrm>
-          <a:prstGeom prst="straightConnector1">
-            <a:avLst/>
-          </a:prstGeom>
-          <a:ln>
-            <a:tailEnd type="triangle"/>
-          </a:ln>
-        </p:spPr>
-        <p:style>
-          <a:lnRef idx="2">
-            <a:schemeClr val="accent1"/>
-          </a:lnRef>
-          <a:fillRef idx="0">
-            <a:schemeClr val="accent1"/>
-          </a:fillRef>
-          <a:effectRef idx="1">
-            <a:schemeClr val="accent1"/>
-          </a:effectRef>
-          <a:fontRef idx="minor">
-            <a:schemeClr val="tx1"/>
-          </a:fontRef>
-        </p:style>
-      </p:cxnSp>
-      <p:sp>
-        <p:nvSpPr>
-          <p:cNvPr id="61" name="TextBox 60">
-            <a:extLst>
-              <a:ext uri="{FF2B5EF4-FFF2-40B4-BE49-F238E27FC236}">
-                <a16:creationId xmlns:a16="http://schemas.microsoft.com/office/drawing/2014/main" id="{D05304AB-6370-5B56-3303-D74D572B9634}"/>
-              </a:ext>
-            </a:extLst>
-          </p:cNvPr>
-          <p:cNvSpPr txBox="1"/>
-          <p:nvPr/>
-        </p:nvSpPr>
-        <p:spPr>
-          <a:xfrm>
-            <a:off x="6214099" y="3935783"/>
-            <a:ext cx="569971" cy="276999"/>
-          </a:xfrm>
-          <a:prstGeom prst="rect">
-            <a:avLst/>
-          </a:prstGeom>
-          <a:noFill/>
-        </p:spPr>
-        <p:txBody>
-          <a:bodyPr wrap="square" rtlCol="0">
-            <a:spAutoFit/>
-          </a:bodyPr>
-          <a:lstStyle/>
-          <a:p>
-            <a:r>
-              <a:rPr lang="en-US" sz="1200" dirty="0"/>
-              <a:t>Yes</a:t>
-            </a:r>
-          </a:p>
-        </p:txBody>
-      </p:sp>
-      <p:sp>
-        <p:nvSpPr>
-          <p:cNvPr id="62" name="Parallelogram 61">
-            <a:extLst>
-              <a:ext uri="{FF2B5EF4-FFF2-40B4-BE49-F238E27FC236}">
-                <a16:creationId xmlns:a16="http://schemas.microsoft.com/office/drawing/2014/main" id="{B32FBDA1-854A-DCAA-D997-AE9DA4F1267C}"/>
-              </a:ext>
-            </a:extLst>
-          </p:cNvPr>
-          <p:cNvSpPr/>
-          <p:nvPr/>
-        </p:nvSpPr>
-        <p:spPr>
-          <a:xfrm>
-            <a:off x="5145768" y="4258871"/>
-            <a:ext cx="1908054" cy="879882"/>
-          </a:xfrm>
-          <a:prstGeom prst="parallelogram">
-            <a:avLst/>
-          </a:prstGeom>
-        </p:spPr>
-        <p:style>
-          <a:lnRef idx="2">
-            <a:schemeClr val="accent6">
-              <a:shade val="15000"/>
-            </a:schemeClr>
-          </a:lnRef>
-          <a:fillRef idx="1">
-            <a:schemeClr val="accent6"/>
-          </a:fillRef>
-          <a:effectRef idx="0">
-            <a:schemeClr val="accent6"/>
-          </a:effectRef>
-          <a:fontRef idx="minor">
-            <a:schemeClr val="lt1"/>
-          </a:fontRef>
-        </p:style>
-        <p:txBody>
-          <a:bodyPr rtlCol="0" anchor="ctr"/>
-          <a:lstStyle/>
-          <a:p>
-            <a:pPr algn="ctr"/>
-            <a:r>
-              <a:rPr lang="en-US" sz="1400" dirty="0"/>
-              <a:t>Enter client’s </a:t>
-            </a:r>
-            <a:r>
-              <a:rPr lang="en-US" sz="1400" dirty="0" err="1"/>
-              <a:t>fname,lname</a:t>
-            </a:r>
-            <a:r>
-              <a:rPr lang="en-US" sz="1400" dirty="0"/>
-              <a:t>, email and password</a:t>
-            </a:r>
-          </a:p>
-        </p:txBody>
-      </p:sp>
-      <p:cxnSp>
-        <p:nvCxnSpPr>
-          <p:cNvPr id="63" name="Straight Arrow Connector 62">
-            <a:extLst>
-              <a:ext uri="{FF2B5EF4-FFF2-40B4-BE49-F238E27FC236}">
-                <a16:creationId xmlns:a16="http://schemas.microsoft.com/office/drawing/2014/main" id="{CC1961F6-9E8B-F7ED-A8F9-2A49D5E2702A}"/>
-              </a:ext>
-            </a:extLst>
-          </p:cNvPr>
-          <p:cNvCxnSpPr>
-            <a:cxnSpLocks/>
-          </p:cNvCxnSpPr>
-          <p:nvPr/>
-        </p:nvCxnSpPr>
-        <p:spPr>
-          <a:xfrm>
-            <a:off x="6156181" y="5148706"/>
-            <a:ext cx="0" cy="262128"/>
-          </a:xfrm>
-          <a:prstGeom prst="straightConnector1">
-            <a:avLst/>
-          </a:prstGeom>
-          <a:ln>
-            <a:tailEnd type="triangle"/>
-          </a:ln>
-        </p:spPr>
-        <p:style>
-          <a:lnRef idx="2">
-            <a:schemeClr val="accent1"/>
-          </a:lnRef>
-          <a:fillRef idx="0">
-            <a:schemeClr val="accent1"/>
-          </a:fillRef>
-          <a:effectRef idx="1">
-            <a:schemeClr val="accent1"/>
-          </a:effectRef>
-          <a:fontRef idx="minor">
-            <a:schemeClr val="tx1"/>
-          </a:fontRef>
-        </p:style>
-      </p:cxnSp>
-      <p:sp>
-        <p:nvSpPr>
-          <p:cNvPr id="64" name="Oval 63">
-            <a:extLst>
-              <a:ext uri="{FF2B5EF4-FFF2-40B4-BE49-F238E27FC236}">
-                <a16:creationId xmlns:a16="http://schemas.microsoft.com/office/drawing/2014/main" id="{F729B793-7207-7D6F-CC1F-E2FF641FB730}"/>
-              </a:ext>
-            </a:extLst>
-          </p:cNvPr>
-          <p:cNvSpPr/>
-          <p:nvPr/>
-        </p:nvSpPr>
-        <p:spPr>
-          <a:xfrm>
-            <a:off x="5485622" y="5410834"/>
-            <a:ext cx="1298448" cy="414528"/>
-          </a:xfrm>
-          <a:prstGeom prst="ellipse">
-            <a:avLst/>
-          </a:prstGeom>
-        </p:spPr>
-        <p:style>
-          <a:lnRef idx="2">
-            <a:schemeClr val="accent2">
-              <a:shade val="15000"/>
-            </a:schemeClr>
-          </a:lnRef>
-          <a:fillRef idx="1">
-            <a:schemeClr val="accent2"/>
-          </a:fillRef>
-          <a:effectRef idx="0">
-            <a:schemeClr val="accent2"/>
-          </a:effectRef>
-          <a:fontRef idx="minor">
-            <a:schemeClr val="lt1"/>
-          </a:fontRef>
-        </p:style>
-        <p:txBody>
-          <a:bodyPr rtlCol="0" anchor="ctr"/>
-          <a:lstStyle/>
-          <a:p>
-            <a:pPr algn="ctr"/>
-            <a:r>
-              <a:rPr lang="en-US" sz="1600" dirty="0"/>
-              <a:t>End</a:t>
-            </a:r>
-            <a:endParaRPr lang="en-US" dirty="0"/>
-          </a:p>
-        </p:txBody>
-      </p:sp>
-      <p:sp>
-        <p:nvSpPr>
-          <p:cNvPr id="65" name="TextBox 64">
-            <a:extLst>
-              <a:ext uri="{FF2B5EF4-FFF2-40B4-BE49-F238E27FC236}">
-                <a16:creationId xmlns:a16="http://schemas.microsoft.com/office/drawing/2014/main" id="{3885512E-6F82-5E53-1260-89AB103402F4}"/>
-              </a:ext>
-            </a:extLst>
-          </p:cNvPr>
-          <p:cNvSpPr txBox="1"/>
-          <p:nvPr/>
-        </p:nvSpPr>
-        <p:spPr>
-          <a:xfrm>
-            <a:off x="5283704" y="3221302"/>
-            <a:ext cx="569971" cy="276999"/>
-          </a:xfrm>
-          <a:prstGeom prst="rect">
-            <a:avLst/>
-          </a:prstGeom>
-          <a:noFill/>
-        </p:spPr>
-        <p:txBody>
-          <a:bodyPr wrap="square" rtlCol="0">
-            <a:spAutoFit/>
-          </a:bodyPr>
-          <a:lstStyle/>
-          <a:p>
-            <a:r>
-              <a:rPr lang="en-US" sz="1200" dirty="0"/>
-              <a:t>No</a:t>
-            </a:r>
-          </a:p>
-        </p:txBody>
-      </p:sp>
-      <p:cxnSp>
-        <p:nvCxnSpPr>
-          <p:cNvPr id="66" name="Straight Arrow Connector 65">
-            <a:extLst>
-              <a:ext uri="{FF2B5EF4-FFF2-40B4-BE49-F238E27FC236}">
-                <a16:creationId xmlns:a16="http://schemas.microsoft.com/office/drawing/2014/main" id="{F3C402A6-64CF-5F32-6DAE-2E52A33C089B}"/>
-              </a:ext>
-            </a:extLst>
-          </p:cNvPr>
-          <p:cNvCxnSpPr>
-            <a:cxnSpLocks/>
-            <a:stCxn id="59" idx="1"/>
-            <a:endCxn id="51" idx="3"/>
-          </p:cNvCxnSpPr>
-          <p:nvPr/>
-        </p:nvCxnSpPr>
-        <p:spPr>
-          <a:xfrm flipH="1" flipV="1">
-            <a:off x="5208649" y="3473549"/>
-            <a:ext cx="403094" cy="24752"/>
-          </a:xfrm>
-          <a:prstGeom prst="straightConnector1">
-            <a:avLst/>
-          </a:prstGeom>
-          <a:ln>
-            <a:tailEnd type="triangle"/>
-          </a:ln>
-        </p:spPr>
-        <p:style>
-          <a:lnRef idx="2">
-            <a:schemeClr val="accent1"/>
-          </a:lnRef>
-          <a:fillRef idx="0">
-            <a:schemeClr val="accent1"/>
-          </a:fillRef>
-          <a:effectRef idx="1">
-            <a:schemeClr val="accent1"/>
-          </a:effectRef>
-          <a:fontRef idx="minor">
-            <a:schemeClr val="tx1"/>
-          </a:fontRef>
-        </p:style>
-      </p:cxnSp>
-      <p:sp>
-        <p:nvSpPr>
           <p:cNvPr id="67" name="Rectangle: Rounded Corners 66">
             <a:extLst>
               <a:ext uri="{FF2B5EF4-FFF2-40B4-BE49-F238E27FC236}">
@@ -5045,6 +4653,45 @@
           <a:xfrm>
             <a:off x="3496804" y="1911096"/>
             <a:ext cx="0" cy="341376"/>
+          </a:xfrm>
+          <a:prstGeom prst="straightConnector1">
+            <a:avLst/>
+          </a:prstGeom>
+          <a:ln>
+            <a:tailEnd type="triangle"/>
+          </a:ln>
+        </p:spPr>
+        <p:style>
+          <a:lnRef idx="2">
+            <a:schemeClr val="accent1"/>
+          </a:lnRef>
+          <a:fillRef idx="0">
+            <a:schemeClr val="accent1"/>
+          </a:fillRef>
+          <a:effectRef idx="1">
+            <a:schemeClr val="accent1"/>
+          </a:effectRef>
+          <a:fontRef idx="minor">
+            <a:schemeClr val="tx1"/>
+          </a:fontRef>
+        </p:style>
+      </p:cxnSp>
+      <p:cxnSp>
+        <p:nvCxnSpPr>
+          <p:cNvPr id="11" name="Straight Arrow Connector 10">
+            <a:extLst>
+              <a:ext uri="{FF2B5EF4-FFF2-40B4-BE49-F238E27FC236}">
+                <a16:creationId xmlns:a16="http://schemas.microsoft.com/office/drawing/2014/main" id="{19446008-FFF3-D668-C65C-E148EF852CB6}"/>
+              </a:ext>
+            </a:extLst>
+          </p:cNvPr>
+          <p:cNvCxnSpPr/>
+          <p:nvPr/>
+        </p:nvCxnSpPr>
+        <p:spPr>
+          <a:xfrm>
+            <a:off x="5982067" y="2682138"/>
+            <a:ext cx="1" cy="475488"/>
           </a:xfrm>
           <a:prstGeom prst="straightConnector1">
             <a:avLst/>

</xml_diff>